<commit_message>
Update documentation and presentation
</commit_message>
<xml_diff>
--- a/documentation/presentation.pptx
+++ b/documentation/presentation.pptx
@@ -122,6 +122,7 @@
 <p1510:revInfo xmlns:a="http://schemas.openxmlformats.org/drawingml/2006/main" xmlns:r="http://schemas.openxmlformats.org/officeDocument/2006/relationships" xmlns:p1510="http://schemas.microsoft.com/office/powerpoint/2015/10/main">
   <p1510:revLst>
     <p1510:client id="{282A828A-EADA-F17D-9EF8-EDEB7AE30384}" v="38" dt="2026-03-24T19:54:10.226"/>
+    <p1510:client id="{B1ED1D0F-CC5D-94E0-74E3-8B7EEFE22072}" v="12" dt="2026-03-24T23:58:46.049"/>
     <p1510:client id="{CCE14515-3107-BBAA-351E-EFFC8FEDA26B}" v="18" dt="2026-03-24T19:38:58.606"/>
   </p1510:revLst>
 </p1510:revInfo>
@@ -208,7 +209,7 @@
           </a:lstStyle>
           <a:p>
             <a:fld id="{35FF1103-E7AA-4EFD-9207-0B4DB64C37DC}" type="datetimeFigureOut">
-              <a:t>24.3.2026 г.</a:t>
+              <a:t>3/24/2026</a:t>
             </a:fld>
             <a:endParaRPr lang="bg-BG"/>
           </a:p>
@@ -2203,7 +2204,7 @@
                 <a:ea typeface="Arial" pitchFamily="34" charset="-122"/>
                 <a:cs typeface="Arial"/>
               </a:rPr>
-              <a:t>Class 9Е</a:t>
+              <a:t>Class 9В</a:t>
             </a:r>
             <a:endParaRPr lang="en-US" sz="1200">
               <a:latin typeface="Arial"/>
@@ -3062,7 +3063,7 @@
                 <a:ea typeface="Arial" pitchFamily="34" charset="-122"/>
                 <a:cs typeface="Arial"/>
               </a:rPr>
-              <a:t>Class 9Е</a:t>
+              <a:t>Class 9В</a:t>
             </a:r>
             <a:endParaRPr lang="en-US" sz="1200" dirty="0"/>
           </a:p>
@@ -5288,17 +5289,16 @@
               <a:buNone/>
             </a:pPr>
             <a:r>
-              <a:rPr lang="en-US" sz="1500" b="1" dirty="0">
+              <a:rPr lang="en-US" sz="1500" b="1" dirty="0" err="1">
                 <a:solidFill>
                   <a:srgbClr val="FFFFFF"/>
                 </a:solidFill>
-                <a:latin typeface="Arial" pitchFamily="34" charset="0"/>
-                <a:ea typeface="Arial" pitchFamily="34" charset="-122"/>
-                <a:cs typeface="Arial" pitchFamily="34" charset="-120"/>
-              </a:rPr>
-              <a:t>std::string</a:t>
-            </a:r>
-            <a:endParaRPr lang="en-US" sz="1500" dirty="0"/>
+                <a:latin typeface="Arial"/>
+                <a:cs typeface="Arial"/>
+              </a:rPr>
+              <a:t>RayLib</a:t>
+            </a:r>
+            <a:endParaRPr lang="en-US" sz="1500" dirty="0" err="1"/>
           </a:p>
         </p:txBody>
       </p:sp>
@@ -5323,21 +5323,17 @@
           <a:bodyPr wrap="square" lIns="0" tIns="0" rIns="0" bIns="0" rtlCol="0" anchor="ctr"/>
           <a:lstStyle/>
           <a:p>
-            <a:pPr marL="0" indent="0" algn="l">
-              <a:buNone/>
-            </a:pPr>
             <a:r>
               <a:rPr lang="en-US" sz="1200" dirty="0">
                 <a:solidFill>
                   <a:srgbClr val="8B949E"/>
                 </a:solidFill>
-                <a:latin typeface="Arial" pitchFamily="34" charset="0"/>
-                <a:ea typeface="Arial" pitchFamily="34" charset="-122"/>
-                <a:cs typeface="Arial" pitchFamily="34" charset="-120"/>
-              </a:rPr>
-              <a:t>All text handling, input/output and data storage</a:t>
-            </a:r>
-            <a:endParaRPr lang="en-US" sz="1200" dirty="0"/>
+                <a:ea typeface="+mn-lt"/>
+                <a:cs typeface="+mn-lt"/>
+              </a:rPr>
+              <a:t>Hardware-accelerated library used for rendering the interactive GUI</a:t>
+            </a:r>
+            <a:endParaRPr lang="en-US" dirty="0"/>
           </a:p>
         </p:txBody>
       </p:sp>

</xml_diff>